<commit_message>
docs(deck): note the Bitbucket-branch source option in the overview deck
Updates the "One tool, from source to sign-off" slide (and speaker notes) to say the
source can be a local checkout OR a Bitbucket branch/tag — the server clones it, so
there's nothing for the release team to install. Regenerated and re-zipped clean
(no empty-dir stubs) so PowerPoint opens it. Generator updated to match.

Co-Authored-By: Claude Opus 4.8 (1M context) <noreply@anthropic.com>
</commit_message>
<xml_diff>
--- a/docs/TraceGuard.pptx
+++ b/docs/TraceGuard.pptx
@@ -685,7 +685,7 @@
           <a:p>
             <a:r>
               <a:rPr lang="en-US" dirty="0"/>
-              <a:t>The three tabs are a workflow, not a menu: Scope then Test then Impact. It serves two apps that differ only in their log markers.</a:t>
+              <a:t>The three tabs are a workflow, not a menu: Scope then Test then Impact. Source can be a local checkout or a Bitbucket branch/tag (the server clones it — no git/helm on the user's machine). It serves two apps that differ only in their log markers.</a:t>
             </a:r>
             <a:endParaRPr lang="en-US" dirty="0"/>
           </a:p>
@@ -3089,7 +3089,7 @@
                 <a:ea typeface="Calibri" pitchFamily="34" charset="-122"/>
                 <a:cs typeface="Calibri" pitchFamily="34" charset="-120"/>
               </a:rPr>
-              <a:t>Point TraceGuard at your framework source — no running system. It reads the Camel routes and controllers, resolves versions, and correlates your logs.</a:t>
+              <a:t>Point TraceGuard at your framework source — a local checkout or a Bitbucket branch / tag, no running system. It reads the Camel routes and controllers, resolves versions, and correlates your logs.</a:t>
             </a:r>
             <a:endParaRPr lang="en-US" sz="1500" dirty="0"/>
           </a:p>
@@ -3726,7 +3726,7 @@
               <a:buNone/>
             </a:pPr>
             <a:r>
-              <a:rPr lang="en-US" sz="1350" i="1" dirty="0">
+              <a:rPr lang="en-US" sz="1300" i="1" dirty="0">
                 <a:solidFill>
                   <a:srgbClr val="5E7488"/>
                 </a:solidFill>
@@ -3734,9 +3734,9 @@
                 <a:ea typeface="Calibri" pitchFamily="34" charset="-122"/>
                 <a:cs typeface="Calibri" pitchFamily="34" charset="-120"/>
               </a:rPr>
-              <a:t>Two applications — Mighty &amp; SPL — traced and analysed separately from one entry point.</a:t>
-            </a:r>
-            <a:endParaRPr lang="en-US" sz="1350" dirty="0"/>
+              <a:t>Two applications (Mighty &amp; SPL) from one entry point  ·  analyse a local path or a Bitbucket branch — nothing for the release team to install.</a:t>
+            </a:r>
+            <a:endParaRPr lang="en-US" sz="1300" dirty="0"/>
           </a:p>
         </p:txBody>
       </p:sp>

</xml_diff>

<commit_message>
docs(deck): make the source-mode line audience-generic
"nothing for the release team to install" -> "nothing to install locally" (and the
speaker note likewise) — the deck is a general overview for multiple audiences, not
release-team-specific. Regenerated and JSZip-repacked.

Co-Authored-By: Claude Opus 4.8 (1M context) <noreply@anthropic.com>
</commit_message>
<xml_diff>
--- a/docs/TraceGuard.pptx
+++ b/docs/TraceGuard.pptx
@@ -685,7 +685,7 @@
           <a:p>
             <a:r>
               <a:rPr lang="en-US" dirty="0"/>
-              <a:t>The three tabs are a workflow, not a menu: Scope then Test then Impact. Source can be a local checkout or a Bitbucket branch/tag (the server clones it — no git/helm on the user's machine). It serves two apps that differ only in their log markers.</a:t>
+              <a:t>The three tabs are a workflow, not a menu: Scope then Test then Impact. Source can be a local checkout or a Bitbucket branch/tag (the server clones it — no git/helm needed locally). It serves two apps that differ only in their log markers.</a:t>
             </a:r>
             <a:endParaRPr lang="en-US" dirty="0"/>
           </a:p>
@@ -3734,7 +3734,7 @@
                 <a:ea typeface="Calibri" pitchFamily="34" charset="-122"/>
                 <a:cs typeface="Calibri" pitchFamily="34" charset="-120"/>
               </a:rPr>
-              <a:t>Two applications (Mighty &amp; SPL) from one entry point  ·  analyse a local path or a Bitbucket branch — nothing for the release team to install.</a:t>
+              <a:t>Two applications (Mighty &amp; SPL) from one entry point  ·  analyse a local path or a Bitbucket branch — nothing to install locally.</a:t>
             </a:r>
             <a:endParaRPr lang="en-US" sz="1300" dirty="0"/>
           </a:p>

</xml_diff>

<commit_message>
docs(deck): use the application's own logo on the title and closing slides
Replaced the placeholder "TG" text shield with the real TraceGuard mark — the
gradient shield + route-graph SVG from the app (AppPicker) rasterised to a
transparent PNG and embedded on both the title and closing slides. The deck now
matches the product's branding. Validated (11 slides, clean LibreOffice
pptx->PDF conversion, both logo slides rendered and checked).

Co-Authored-By: Claude Opus 4.8 (1M context) <noreply@anthropic.com>
</commit_message>
<xml_diff>
--- a/docs/TraceGuard.pptx
+++ b/docs/TraceGuard.pptx
@@ -1785,92 +1785,33 @@
           <a:ln/>
         </p:spPr>
       </p:sp>
-      <p:sp>
-        <p:nvSpPr>
-          <p:cNvPr id="3" name="Shape 1"/>
-          <p:cNvSpPr/>
-          <p:nvPr/>
-        </p:nvSpPr>
-        <p:spPr>
-          <a:xfrm>
-            <a:off x="9784080" y="1737360"/>
-            <a:ext cx="1737360" cy="2103120"/>
-          </a:xfrm>
-          <a:prstGeom prst="roundRect">
-            <a:avLst>
-              <a:gd name="adj" fmla="val 26316"/>
-            </a:avLst>
-          </a:prstGeom>
-          <a:solidFill>
-            <a:srgbClr val="2563EB"/>
-          </a:solidFill>
-          <a:ln/>
-        </p:spPr>
-      </p:sp>
-      <p:sp>
-        <p:nvSpPr>
-          <p:cNvPr id="4" name="Shape 2"/>
-          <p:cNvSpPr/>
-          <p:nvPr/>
-        </p:nvSpPr>
-        <p:spPr>
-          <a:xfrm>
-            <a:off x="10012680" y="1965960"/>
-            <a:ext cx="1280160" cy="1645920"/>
-          </a:xfrm>
-          <a:prstGeom prst="roundRect">
-            <a:avLst>
-              <a:gd name="adj" fmla="val 28571"/>
-            </a:avLst>
-          </a:prstGeom>
-          <a:solidFill>
-            <a:srgbClr val="0891B2"/>
-          </a:solidFill>
-          <a:ln/>
-        </p:spPr>
-      </p:sp>
-      <p:sp>
-        <p:nvSpPr>
-          <p:cNvPr id="5" name="Text 3"/>
-          <p:cNvSpPr/>
-          <p:nvPr/>
-        </p:nvSpPr>
-        <p:spPr>
-          <a:xfrm>
-            <a:off x="9784080" y="2148840"/>
-            <a:ext cx="1737360" cy="1005840"/>
-          </a:xfrm>
-          <a:prstGeom prst="rect">
-            <a:avLst/>
-          </a:prstGeom>
-          <a:noFill/>
-          <a:ln/>
-        </p:spPr>
-        <p:txBody>
-          <a:bodyPr wrap="square" lIns="0" tIns="0" rIns="0" bIns="0" rtlCol="0" anchor="ctr"/>
-          <a:lstStyle/>
-          <a:p>
-            <a:pPr algn="ctr" indent="0" marL="0">
-              <a:buNone/>
-            </a:pPr>
-            <a:r>
-              <a:rPr lang="en-US" sz="3400" b="1" dirty="0">
-                <a:solidFill>
-                  <a:srgbClr val="FFFFFF"/>
-                </a:solidFill>
-                <a:latin typeface="Calibri" pitchFamily="34" charset="0"/>
-                <a:ea typeface="Calibri" pitchFamily="34" charset="-122"/>
-                <a:cs typeface="Calibri" pitchFamily="34" charset="-120"/>
-              </a:rPr>
-              <a:t>TG</a:t>
-            </a:r>
-            <a:endParaRPr lang="en-US" sz="3400" dirty="0"/>
-          </a:p>
-        </p:txBody>
-      </p:sp>
-      <p:sp>
-        <p:nvSpPr>
-          <p:cNvPr id="6" name="Text 4"/>
+      <p:pic>
+        <p:nvPicPr>
+          <p:cNvPr id="3" name="Image 0" descr="preencoded.png">    </p:cNvPr>
+          <p:cNvPicPr>
+            <a:picLocks noChangeAspect="1"/>
+          </p:cNvPicPr>
+          <p:nvPr/>
+        </p:nvPicPr>
+        <p:blipFill>
+          <a:blip r:embed="rId1"/>
+          <a:stretch>
+            <a:fillRect/>
+          </a:stretch>
+        </p:blipFill>
+        <p:spPr>
+          <a:xfrm>
+            <a:off x="9829800" y="1828800"/>
+            <a:ext cx="1874520" cy="1874520"/>
+          </a:xfrm>
+          <a:prstGeom prst="rect">
+            <a:avLst/>
+          </a:prstGeom>
+        </p:spPr>
+      </p:pic>
+      <p:sp>
+        <p:nvSpPr>
+          <p:cNvPr id="4" name="Text 1"/>
           <p:cNvSpPr/>
           <p:nvPr/>
         </p:nvSpPr>
@@ -1909,7 +1850,7 @@
       </p:sp>
       <p:sp>
         <p:nvSpPr>
-          <p:cNvPr id="7" name="Text 5"/>
+          <p:cNvPr id="5" name="Text 2"/>
           <p:cNvSpPr/>
           <p:nvPr/>
         </p:nvSpPr>
@@ -1948,7 +1889,7 @@
       </p:sp>
       <p:sp>
         <p:nvSpPr>
-          <p:cNvPr id="8" name="Text 6"/>
+          <p:cNvPr id="6" name="Text 3"/>
           <p:cNvSpPr/>
           <p:nvPr/>
         </p:nvSpPr>
@@ -1987,7 +1928,7 @@
       </p:sp>
       <p:sp>
         <p:nvSpPr>
-          <p:cNvPr id="9" name="Text 7"/>
+          <p:cNvPr id="7" name="Text 4"/>
           <p:cNvSpPr/>
           <p:nvPr/>
         </p:nvSpPr>
@@ -2029,7 +1970,7 @@
       </p:sp>
       <p:sp>
         <p:nvSpPr>
-          <p:cNvPr id="10" name="Text 8"/>
+          <p:cNvPr id="8" name="Text 5"/>
           <p:cNvSpPr/>
           <p:nvPr/>
         </p:nvSpPr>
@@ -2904,92 +2845,33 @@
           <a:chExt cx="0" cy="0"/>
         </a:xfrm>
       </p:grpSpPr>
-      <p:sp>
-        <p:nvSpPr>
-          <p:cNvPr id="2" name="Shape 0"/>
-          <p:cNvSpPr/>
-          <p:nvPr/>
-        </p:nvSpPr>
-        <p:spPr>
-          <a:xfrm>
-            <a:off x="9784080" y="1600200"/>
-            <a:ext cx="1737360" cy="2103120"/>
-          </a:xfrm>
-          <a:prstGeom prst="roundRect">
-            <a:avLst>
-              <a:gd name="adj" fmla="val 26316"/>
-            </a:avLst>
-          </a:prstGeom>
-          <a:solidFill>
-            <a:srgbClr val="2563EB"/>
-          </a:solidFill>
-          <a:ln/>
-        </p:spPr>
-      </p:sp>
-      <p:sp>
-        <p:nvSpPr>
-          <p:cNvPr id="3" name="Shape 1"/>
-          <p:cNvSpPr/>
-          <p:nvPr/>
-        </p:nvSpPr>
-        <p:spPr>
-          <a:xfrm>
-            <a:off x="10012680" y="1828800"/>
-            <a:ext cx="1280160" cy="1645920"/>
-          </a:xfrm>
-          <a:prstGeom prst="roundRect">
-            <a:avLst>
-              <a:gd name="adj" fmla="val 28571"/>
-            </a:avLst>
-          </a:prstGeom>
-          <a:solidFill>
-            <a:srgbClr val="0891B2"/>
-          </a:solidFill>
-          <a:ln/>
-        </p:spPr>
-      </p:sp>
-      <p:sp>
-        <p:nvSpPr>
-          <p:cNvPr id="4" name="Text 2"/>
-          <p:cNvSpPr/>
-          <p:nvPr/>
-        </p:nvSpPr>
-        <p:spPr>
-          <a:xfrm>
-            <a:off x="9784080" y="2011680"/>
-            <a:ext cx="1737360" cy="1005840"/>
-          </a:xfrm>
-          <a:prstGeom prst="rect">
-            <a:avLst/>
-          </a:prstGeom>
-          <a:noFill/>
-          <a:ln/>
-        </p:spPr>
-        <p:txBody>
-          <a:bodyPr wrap="square" lIns="0" tIns="0" rIns="0" bIns="0" rtlCol="0" anchor="ctr"/>
-          <a:lstStyle/>
-          <a:p>
-            <a:pPr algn="ctr" indent="0" marL="0">
-              <a:buNone/>
-            </a:pPr>
-            <a:r>
-              <a:rPr lang="en-US" sz="3000" b="1" dirty="0">
-                <a:solidFill>
-                  <a:srgbClr val="FFFFFF"/>
-                </a:solidFill>
-                <a:latin typeface="Calibri" pitchFamily="34" charset="0"/>
-                <a:ea typeface="Calibri" pitchFamily="34" charset="-122"/>
-                <a:cs typeface="Calibri" pitchFamily="34" charset="-120"/>
-              </a:rPr>
-              <a:t>TG</a:t>
-            </a:r>
-            <a:endParaRPr lang="en-US" sz="3000" dirty="0"/>
-          </a:p>
-        </p:txBody>
-      </p:sp>
-      <p:sp>
-        <p:nvSpPr>
-          <p:cNvPr id="5" name="Text 3"/>
+      <p:pic>
+        <p:nvPicPr>
+          <p:cNvPr id="2" name="Image 0" descr="preencoded.png">    </p:cNvPr>
+          <p:cNvPicPr>
+            <a:picLocks noChangeAspect="1"/>
+          </p:cNvPicPr>
+          <p:nvPr/>
+        </p:nvPicPr>
+        <p:blipFill>
+          <a:blip r:embed="rId1"/>
+          <a:stretch>
+            <a:fillRect/>
+          </a:stretch>
+        </p:blipFill>
+        <p:spPr>
+          <a:xfrm>
+            <a:off x="9829800" y="1691640"/>
+            <a:ext cx="1874520" cy="1874520"/>
+          </a:xfrm>
+          <a:prstGeom prst="rect">
+            <a:avLst/>
+          </a:prstGeom>
+        </p:spPr>
+      </p:pic>
+      <p:sp>
+        <p:nvSpPr>
+          <p:cNvPr id="3" name="Text 0"/>
           <p:cNvSpPr/>
           <p:nvPr/>
         </p:nvSpPr>
@@ -3028,7 +2910,7 @@
       </p:sp>
       <p:sp>
         <p:nvSpPr>
-          <p:cNvPr id="6" name="Text 4"/>
+          <p:cNvPr id="4" name="Text 1"/>
           <p:cNvSpPr/>
           <p:nvPr/>
         </p:nvSpPr>
@@ -3090,7 +2972,7 @@
       </p:sp>
       <p:sp>
         <p:nvSpPr>
-          <p:cNvPr id="7" name="Text 5"/>
+          <p:cNvPr id="5" name="Text 2"/>
           <p:cNvSpPr/>
           <p:nvPr/>
         </p:nvSpPr>
@@ -3132,7 +3014,7 @@
       </p:sp>
       <p:sp>
         <p:nvSpPr>
-          <p:cNvPr id="8" name="Text 6"/>
+          <p:cNvPr id="6" name="Text 3"/>
           <p:cNvSpPr/>
           <p:nvPr/>
         </p:nvSpPr>

</xml_diff>

<commit_message>
docs(deck): update TraceGuard deck for multi-module
- New slide 8, "The whole release, every module in one scan": four cards —
  every repo one scan, grouped by module, readiness at a glance (At risk /
  Review / Ready), clean per-module attribution.
- Slide "Built for your codebase": reframed the Multiple-applications card to
  "each remembers its own module list, country and context".
- Slide "How teams run it": replaced the removed "Dependency sources" item with
  "App module config" (per-app module list prepopulated, editable, save-as-default).

Rendered all 12 slides via LibreOffice to verify layout/fit.

Co-Authored-By: Claude Opus 4.8 (1M context) <noreply@anthropic.com>
</commit_message>
<xml_diff>
--- a/docs/TraceGuard.pptx
+++ b/docs/TraceGuard.pptx
@@ -12,6 +12,7 @@
     <p:sldId id="260" r:id="rId6"/>
     <p:sldId id="261" r:id="rId7"/>
     <p:sldId id="262" r:id="rId8"/>
+    <p:sldId id="267" r:id="rId18"/>
     <p:sldId id="263" r:id="rId9"/>
     <p:sldId id="264" r:id="rId10"/>
     <p:sldId id="265" r:id="rId11"/>
@@ -3059,6 +3060,576 @@
 </p:sld>
 </file>
 
+<file path=ppt/slides/slide12.xml><?xml version="1.0" encoding="utf-8"?>
+<p:sld xmlns:a="http://schemas.openxmlformats.org/drawingml/2006/main" xmlns:r="http://schemas.openxmlformats.org/officeDocument/2006/relationships" xmlns:p="http://schemas.openxmlformats.org/presentationml/2006/main">
+  <p:cSld name="Slide 8">
+    <p:bg>
+      <p:bgPr>
+        <a:solidFill>
+          <a:srgbClr val="FFFFFF"/>
+        </a:solidFill>
+      </p:bgPr>
+    </p:bg>
+    <p:spTree>
+      <p:nvGrpSpPr>
+        <p:cNvPr id="1" name=""/>
+        <p:cNvGrpSpPr/>
+        <p:nvPr/>
+      </p:nvGrpSpPr>
+      <p:grpSpPr>
+        <a:xfrm>
+          <a:off x="0" y="0"/>
+          <a:ext cx="0" cy="0"/>
+          <a:chOff x="0" y="0"/>
+          <a:chExt cx="0" cy="0"/>
+        </a:xfrm>
+      </p:grpSpPr>
+      <p:sp>
+        <p:nvSpPr>
+          <p:cNvPr id="2" name="Text 0"/>
+          <p:cNvSpPr/>
+          <p:nvPr/>
+        </p:nvSpPr>
+        <p:spPr>
+          <a:xfrm>
+            <a:off x="640080" y="502920"/>
+            <a:ext cx="5486400" cy="274320"/>
+          </a:xfrm>
+          <a:prstGeom prst="rect">
+            <a:avLst/>
+          </a:prstGeom>
+          <a:noFill/>
+          <a:ln/>
+        </p:spPr>
+        <p:txBody>
+          <a:bodyPr wrap="square" lIns="0" tIns="0" rIns="0" bIns="0" rtlCol="0" anchor="ctr"/>
+          <a:lstStyle/>
+          <a:p>
+            <a:pPr algn="l" indent="0" marL="0">
+              <a:buNone/>
+            </a:pPr>
+            <a:r>
+              <a:rPr lang="en-US" sz="1200" b="1" spc="200" kern="0" dirty="0">
+                <a:solidFill>
+                  <a:srgbClr val="2563EB"/>
+                </a:solidFill>
+                <a:latin typeface="Calibri" pitchFamily="34" charset="0"/>
+                <a:ea typeface="Calibri" pitchFamily="34" charset="-122"/>
+                <a:cs typeface="Calibri" pitchFamily="34" charset="-120"/>
+              </a:rPr>
+              <a:t>ONE RELEASE, EVERY MODULE</a:t>
+            </a:r>
+            <a:endParaRPr lang="en-US" sz="1200" dirty="0"/>
+          </a:p>
+        </p:txBody>
+      </p:sp>
+      <p:sp>
+        <p:nvSpPr>
+          <p:cNvPr id="3" name="Text 1"/>
+          <p:cNvSpPr/>
+          <p:nvPr/>
+        </p:nvSpPr>
+        <p:spPr>
+          <a:xfrm>
+            <a:off x="640080" y="822960"/>
+            <a:ext cx="10911535" cy="914400"/>
+          </a:xfrm>
+          <a:prstGeom prst="rect">
+            <a:avLst/>
+          </a:prstGeom>
+          <a:noFill/>
+          <a:ln/>
+        </p:spPr>
+        <p:txBody>
+          <a:bodyPr wrap="square" lIns="0" tIns="0" rIns="0" bIns="0" rtlCol="0" anchor="ctr"/>
+          <a:lstStyle/>
+          <a:p>
+            <a:pPr algn="l" indent="0" marL="0">
+              <a:buNone/>
+            </a:pPr>
+            <a:r>
+              <a:rPr lang="en-US" sz="3000" b="1" dirty="0">
+                <a:solidFill>
+                  <a:srgbClr val="17233B"/>
+                </a:solidFill>
+                <a:latin typeface="Calibri" pitchFamily="34" charset="0"/>
+                <a:ea typeface="Calibri" pitchFamily="34" charset="-122"/>
+                <a:cs typeface="Calibri" pitchFamily="34" charset="-120"/>
+              </a:rPr>
+              <a:t>The whole release, every module in one scan</a:t>
+            </a:r>
+            <a:endParaRPr lang="en-US" sz="3000" dirty="0"/>
+          </a:p>
+        </p:txBody>
+      </p:sp>
+      <p:sp>
+        <p:nvSpPr>
+          <p:cNvPr id="4" name="Shape 2"/>
+          <p:cNvSpPr/>
+          <p:nvPr/>
+        </p:nvSpPr>
+        <p:spPr>
+          <a:xfrm>
+            <a:off x="640080" y="1965960"/>
+            <a:ext cx="5364328" cy="1417320"/>
+          </a:xfrm>
+          <a:prstGeom prst="roundRect">
+            <a:avLst>
+              <a:gd name="adj" fmla="val 5806"/>
+            </a:avLst>
+          </a:prstGeom>
+          <a:solidFill>
+            <a:srgbClr val="EFF6FF"/>
+          </a:solidFill>
+          <a:ln w="12700">
+            <a:solidFill>
+              <a:srgbClr val="D7E0EE"/>
+            </a:solidFill>
+            <a:prstDash val="solid"/>
+          </a:ln>
+          <a:effectLst>
+            <a:outerShdw sx="100000" sy="100000" kx="0" ky="0" algn="bl" rotWithShape="0" blurRad="114300" dist="38100" dir="5400000">
+              <a:srgbClr val="0B1020">
+                <a:alpha val="18000"/>
+              </a:srgbClr>
+            </a:outerShdw>
+          </a:effectLst>
+        </p:spPr>
+      </p:sp>
+      <p:sp>
+        <p:nvSpPr>
+          <p:cNvPr id="5" name="Text 3"/>
+          <p:cNvSpPr/>
+          <p:nvPr/>
+        </p:nvSpPr>
+        <p:spPr>
+          <a:xfrm>
+            <a:off x="960120" y="2221992"/>
+            <a:ext cx="4769968" cy="411480"/>
+          </a:xfrm>
+          <a:prstGeom prst="rect">
+            <a:avLst/>
+          </a:prstGeom>
+          <a:noFill/>
+          <a:ln/>
+        </p:spPr>
+        <p:txBody>
+          <a:bodyPr wrap="square" lIns="0" tIns="0" rIns="0" bIns="0" rtlCol="0" anchor="ctr"/>
+          <a:lstStyle/>
+          <a:p>
+            <a:pPr algn="l" indent="0" marL="0">
+              <a:buNone/>
+            </a:pPr>
+            <a:r>
+              <a:rPr lang="en-US" sz="1700" b="1" dirty="0">
+                <a:solidFill>
+                  <a:srgbClr val="2563EB"/>
+                </a:solidFill>
+                <a:latin typeface="Calibri" pitchFamily="34" charset="0"/>
+                <a:ea typeface="Calibri" pitchFamily="34" charset="-122"/>
+                <a:cs typeface="Calibri" pitchFamily="34" charset="-120"/>
+              </a:rPr>
+              <a:t>Every repo, one scan</a:t>
+            </a:r>
+            <a:endParaRPr lang="en-US" sz="1700" dirty="0"/>
+          </a:p>
+        </p:txBody>
+      </p:sp>
+      <p:sp>
+        <p:nvSpPr>
+          <p:cNvPr id="6" name="Text 4"/>
+          <p:cNvSpPr/>
+          <p:nvPr/>
+        </p:nvSpPr>
+        <p:spPr>
+          <a:xfrm>
+            <a:off x="960120" y="2624328"/>
+            <a:ext cx="4769968" cy="685800"/>
+          </a:xfrm>
+          <a:prstGeom prst="rect">
+            <a:avLst/>
+          </a:prstGeom>
+          <a:noFill/>
+          <a:ln/>
+        </p:spPr>
+        <p:txBody>
+          <a:bodyPr wrap="square" lIns="0" tIns="0" rIns="0" bIns="0" rtlCol="0" anchor="ctr"/>
+          <a:lstStyle/>
+          <a:p>
+            <a:pPr algn="l" indent="0" marL="0">
+              <a:lnSpc>
+                <a:spcPct val="112000"/>
+              </a:lnSpc>
+              <a:buNone/>
+            </a:pPr>
+            <a:r>
+              <a:rPr lang="en-US" sz="1350" dirty="0">
+                <a:solidFill>
+                  <a:srgbClr val="5B6B85"/>
+                </a:solidFill>
+                <a:latin typeface="Calibri" pitchFamily="34" charset="0"/>
+                <a:ea typeface="Calibri" pitchFamily="34" charset="-122"/>
+                <a:cs typeface="Calibri" pitchFamily="34" charset="-120"/>
+              </a:rPr>
+              <a:t>Point at the entry app and its sub-modules — the whole release scans in one pass.</a:t>
+            </a:r>
+            <a:endParaRPr lang="en-US" sz="1350" dirty="0"/>
+          </a:p>
+        </p:txBody>
+      </p:sp>
+      <p:sp>
+        <p:nvSpPr>
+          <p:cNvPr id="7" name="Shape 5"/>
+          <p:cNvSpPr/>
+          <p:nvPr/>
+        </p:nvSpPr>
+        <p:spPr>
+          <a:xfrm>
+            <a:off x="6187288" y="1965960"/>
+            <a:ext cx="5364328" cy="1417320"/>
+          </a:xfrm>
+          <a:prstGeom prst="roundRect">
+            <a:avLst>
+              <a:gd name="adj" fmla="val 5806"/>
+            </a:avLst>
+          </a:prstGeom>
+          <a:solidFill>
+            <a:srgbClr val="EFF6FF"/>
+          </a:solidFill>
+          <a:ln w="12700">
+            <a:solidFill>
+              <a:srgbClr val="D7E0EE"/>
+            </a:solidFill>
+            <a:prstDash val="solid"/>
+          </a:ln>
+          <a:effectLst>
+            <a:outerShdw sx="100000" sy="100000" kx="0" ky="0" algn="bl" rotWithShape="0" blurRad="114300" dist="38100" dir="5400000">
+              <a:srgbClr val="0B1020">
+                <a:alpha val="18000"/>
+              </a:srgbClr>
+            </a:outerShdw>
+          </a:effectLst>
+        </p:spPr>
+      </p:sp>
+      <p:sp>
+        <p:nvSpPr>
+          <p:cNvPr id="8" name="Text 6"/>
+          <p:cNvSpPr/>
+          <p:nvPr/>
+        </p:nvSpPr>
+        <p:spPr>
+          <a:xfrm>
+            <a:off x="6507328" y="2221992"/>
+            <a:ext cx="4769968" cy="411480"/>
+          </a:xfrm>
+          <a:prstGeom prst="rect">
+            <a:avLst/>
+          </a:prstGeom>
+          <a:noFill/>
+          <a:ln/>
+        </p:spPr>
+        <p:txBody>
+          <a:bodyPr wrap="square" lIns="0" tIns="0" rIns="0" bIns="0" rtlCol="0" anchor="ctr"/>
+          <a:lstStyle/>
+          <a:p>
+            <a:pPr algn="l" indent="0" marL="0">
+              <a:buNone/>
+            </a:pPr>
+            <a:r>
+              <a:rPr lang="en-US" sz="1700" b="1" dirty="0">
+                <a:solidFill>
+                  <a:srgbClr val="2563EB"/>
+                </a:solidFill>
+                <a:latin typeface="Calibri" pitchFamily="34" charset="0"/>
+                <a:ea typeface="Calibri" pitchFamily="34" charset="-122"/>
+                <a:cs typeface="Calibri" pitchFamily="34" charset="-120"/>
+              </a:rPr>
+              <a:t>Grouped by module</a:t>
+            </a:r>
+            <a:endParaRPr lang="en-US" sz="1700" dirty="0"/>
+          </a:p>
+        </p:txBody>
+      </p:sp>
+      <p:sp>
+        <p:nvSpPr>
+          <p:cNvPr id="9" name="Text 7"/>
+          <p:cNvSpPr/>
+          <p:nvPr/>
+        </p:nvSpPr>
+        <p:spPr>
+          <a:xfrm>
+            <a:off x="6507328" y="2624328"/>
+            <a:ext cx="4769968" cy="685800"/>
+          </a:xfrm>
+          <a:prstGeom prst="rect">
+            <a:avLst/>
+          </a:prstGeom>
+          <a:noFill/>
+          <a:ln/>
+        </p:spPr>
+        <p:txBody>
+          <a:bodyPr wrap="square" lIns="0" tIns="0" rIns="0" bIns="0" rtlCol="0" anchor="ctr"/>
+          <a:lstStyle/>
+          <a:p>
+            <a:pPr algn="l" indent="0" marL="0">
+              <a:lnSpc>
+                <a:spcPct val="112000"/>
+              </a:lnSpc>
+              <a:buNone/>
+            </a:pPr>
+            <a:r>
+              <a:rPr lang="en-US" sz="1350" dirty="0">
+                <a:solidFill>
+                  <a:srgbClr val="5B6B85"/>
+                </a:solidFill>
+                <a:latin typeface="Calibri" pitchFamily="34" charset="0"/>
+                <a:ea typeface="Calibri" pitchFamily="34" charset="-122"/>
+                <a:cs typeface="Calibri" pitchFamily="34" charset="-120"/>
+              </a:rPr>
+              <a:t>Scope, Test and Impact group results by module — one report per workflow.</a:t>
+            </a:r>
+            <a:endParaRPr lang="en-US" sz="1350" dirty="0"/>
+          </a:p>
+        </p:txBody>
+      </p:sp>
+      <p:sp>
+        <p:nvSpPr>
+          <p:cNvPr id="10" name="Shape 8"/>
+          <p:cNvSpPr/>
+          <p:nvPr/>
+        </p:nvSpPr>
+        <p:spPr>
+          <a:xfrm>
+            <a:off x="640080" y="3566160"/>
+            <a:ext cx="5364328" cy="1417320"/>
+          </a:xfrm>
+          <a:prstGeom prst="roundRect">
+            <a:avLst>
+              <a:gd name="adj" fmla="val 5806"/>
+            </a:avLst>
+          </a:prstGeom>
+          <a:solidFill>
+            <a:srgbClr val="EFF6FF"/>
+          </a:solidFill>
+          <a:ln w="12700">
+            <a:solidFill>
+              <a:srgbClr val="D7E0EE"/>
+            </a:solidFill>
+            <a:prstDash val="solid"/>
+          </a:ln>
+          <a:effectLst>
+            <a:outerShdw sx="100000" sy="100000" kx="0" ky="0" algn="bl" rotWithShape="0" blurRad="114300" dist="38100" dir="5400000">
+              <a:srgbClr val="0B1020">
+                <a:alpha val="18000"/>
+              </a:srgbClr>
+            </a:outerShdw>
+          </a:effectLst>
+        </p:spPr>
+      </p:sp>
+      <p:sp>
+        <p:nvSpPr>
+          <p:cNvPr id="11" name="Text 9"/>
+          <p:cNvSpPr/>
+          <p:nvPr/>
+        </p:nvSpPr>
+        <p:spPr>
+          <a:xfrm>
+            <a:off x="960120" y="3822192"/>
+            <a:ext cx="4769968" cy="411480"/>
+          </a:xfrm>
+          <a:prstGeom prst="rect">
+            <a:avLst/>
+          </a:prstGeom>
+          <a:noFill/>
+          <a:ln/>
+        </p:spPr>
+        <p:txBody>
+          <a:bodyPr wrap="square" lIns="0" tIns="0" rIns="0" bIns="0" rtlCol="0" anchor="ctr"/>
+          <a:lstStyle/>
+          <a:p>
+            <a:pPr algn="l" indent="0" marL="0">
+              <a:buNone/>
+            </a:pPr>
+            <a:r>
+              <a:rPr lang="en-US" sz="1700" b="1" dirty="0">
+                <a:solidFill>
+                  <a:srgbClr val="2563EB"/>
+                </a:solidFill>
+                <a:latin typeface="Calibri" pitchFamily="34" charset="0"/>
+                <a:ea typeface="Calibri" pitchFamily="34" charset="-122"/>
+                <a:cs typeface="Calibri" pitchFamily="34" charset="-120"/>
+              </a:rPr>
+              <a:t>Readiness at a glance</a:t>
+            </a:r>
+            <a:endParaRPr lang="en-US" sz="1700" dirty="0"/>
+          </a:p>
+        </p:txBody>
+      </p:sp>
+      <p:sp>
+        <p:nvSpPr>
+          <p:cNvPr id="12" name="Text 10"/>
+          <p:cNvSpPr/>
+          <p:nvPr/>
+        </p:nvSpPr>
+        <p:spPr>
+          <a:xfrm>
+            <a:off x="960120" y="4224528"/>
+            <a:ext cx="4769968" cy="685800"/>
+          </a:xfrm>
+          <a:prstGeom prst="rect">
+            <a:avLst/>
+          </a:prstGeom>
+          <a:noFill/>
+          <a:ln/>
+        </p:spPr>
+        <p:txBody>
+          <a:bodyPr wrap="square" lIns="0" tIns="0" rIns="0" bIns="0" rtlCol="0" anchor="ctr"/>
+          <a:lstStyle/>
+          <a:p>
+            <a:pPr algn="l" indent="0" marL="0">
+              <a:lnSpc>
+                <a:spcPct val="112000"/>
+              </a:lnSpc>
+              <a:buNone/>
+            </a:pPr>
+            <a:r>
+              <a:rPr lang="en-US" sz="1350" dirty="0">
+                <a:solidFill>
+                  <a:srgbClr val="5B6B85"/>
+                </a:solidFill>
+                <a:latin typeface="Calibri" pitchFamily="34" charset="0"/>
+                <a:ea typeface="Calibri" pitchFamily="34" charset="-122"/>
+                <a:cs typeface="Calibri" pitchFamily="34" charset="-120"/>
+              </a:rPr>
+              <a:t>A per-module rollup with At risk / Review / Ready — worst first, so gaps stand out.</a:t>
+            </a:r>
+            <a:endParaRPr lang="en-US" sz="1350" dirty="0"/>
+          </a:p>
+        </p:txBody>
+      </p:sp>
+      <p:sp>
+        <p:nvSpPr>
+          <p:cNvPr id="13" name="Shape 11"/>
+          <p:cNvSpPr/>
+          <p:nvPr/>
+        </p:nvSpPr>
+        <p:spPr>
+          <a:xfrm>
+            <a:off x="6187288" y="3566160"/>
+            <a:ext cx="5364328" cy="1417320"/>
+          </a:xfrm>
+          <a:prstGeom prst="roundRect">
+            <a:avLst>
+              <a:gd name="adj" fmla="val 5806"/>
+            </a:avLst>
+          </a:prstGeom>
+          <a:solidFill>
+            <a:srgbClr val="EFF6FF"/>
+          </a:solidFill>
+          <a:ln w="12700">
+            <a:solidFill>
+              <a:srgbClr val="D7E0EE"/>
+            </a:solidFill>
+            <a:prstDash val="solid"/>
+          </a:ln>
+          <a:effectLst>
+            <a:outerShdw sx="100000" sy="100000" kx="0" ky="0" algn="bl" rotWithShape="0" blurRad="114300" dist="38100" dir="5400000">
+              <a:srgbClr val="0B1020">
+                <a:alpha val="18000"/>
+              </a:srgbClr>
+            </a:outerShdw>
+          </a:effectLst>
+        </p:spPr>
+      </p:sp>
+      <p:sp>
+        <p:nvSpPr>
+          <p:cNvPr id="14" name="Text 12"/>
+          <p:cNvSpPr/>
+          <p:nvPr/>
+        </p:nvSpPr>
+        <p:spPr>
+          <a:xfrm>
+            <a:off x="6507328" y="3822192"/>
+            <a:ext cx="4769968" cy="411480"/>
+          </a:xfrm>
+          <a:prstGeom prst="rect">
+            <a:avLst/>
+          </a:prstGeom>
+          <a:noFill/>
+          <a:ln/>
+        </p:spPr>
+        <p:txBody>
+          <a:bodyPr wrap="square" lIns="0" tIns="0" rIns="0" bIns="0" rtlCol="0" anchor="ctr"/>
+          <a:lstStyle/>
+          <a:p>
+            <a:pPr algn="l" indent="0" marL="0">
+              <a:buNone/>
+            </a:pPr>
+            <a:r>
+              <a:rPr lang="en-US" sz="1700" b="1" dirty="0">
+                <a:solidFill>
+                  <a:srgbClr val="2563EB"/>
+                </a:solidFill>
+                <a:latin typeface="Calibri" pitchFamily="34" charset="0"/>
+                <a:ea typeface="Calibri" pitchFamily="34" charset="-122"/>
+                <a:cs typeface="Calibri" pitchFamily="34" charset="-120"/>
+              </a:rPr>
+              <a:t>Clean attribution</a:t>
+            </a:r>
+            <a:endParaRPr lang="en-US" sz="1700" dirty="0"/>
+          </a:p>
+        </p:txBody>
+      </p:sp>
+      <p:sp>
+        <p:nvSpPr>
+          <p:cNvPr id="15" name="Text 13"/>
+          <p:cNvSpPr/>
+          <p:nvPr/>
+        </p:nvSpPr>
+        <p:spPr>
+          <a:xfrm>
+            <a:off x="6507328" y="4224528"/>
+            <a:ext cx="4769968" cy="685800"/>
+          </a:xfrm>
+          <a:prstGeom prst="rect">
+            <a:avLst/>
+          </a:prstGeom>
+          <a:noFill/>
+          <a:ln/>
+        </p:spPr>
+        <p:txBody>
+          <a:bodyPr wrap="square" lIns="0" tIns="0" rIns="0" bIns="0" rtlCol="0" anchor="ctr"/>
+          <a:lstStyle/>
+          <a:p>
+            <a:pPr algn="l" indent="0" marL="0">
+              <a:lnSpc>
+                <a:spcPct val="112000"/>
+              </a:lnSpc>
+              <a:buNone/>
+            </a:pPr>
+            <a:r>
+              <a:rPr lang="en-US" sz="1350" dirty="0">
+                <a:solidFill>
+                  <a:srgbClr val="5B6B85"/>
+                </a:solidFill>
+                <a:latin typeface="Calibri" pitchFamily="34" charset="0"/>
+                <a:ea typeface="Calibri" pitchFamily="34" charset="-122"/>
+                <a:cs typeface="Calibri" pitchFamily="34" charset="-120"/>
+              </a:rPr>
+              <a:t>Each API is credited to the module that owns it — no cross-module double-counting.</a:t>
+            </a:r>
+            <a:endParaRPr lang="en-US" sz="1350" dirty="0"/>
+          </a:p>
+        </p:txBody>
+      </p:sp>
+    </p:spTree>
+  </p:cSld>
+  <p:clrMapOvr>
+    <a:masterClrMapping/>
+  </p:clrMapOvr>
+</p:sld>
+</file>
+
 <file path=ppt/slides/slide2.xml><?xml version="1.0" encoding="utf-8"?>
 <p:sld xmlns:a="http://schemas.openxmlformats.org/drawingml/2006/main" xmlns:r="http://schemas.openxmlformats.org/officeDocument/2006/relationships" xmlns:p="http://schemas.openxmlformats.org/presentationml/2006/main">
   <p:cSld name="Slide 2">
@@ -7379,7 +7950,7 @@
                 <a:ea typeface="Calibri" pitchFamily="34" charset="-122"/>
                 <a:cs typeface="Calibri" pitchFamily="34" charset="-120"/>
               </a:rPr>
-              <a:t>Trace Mighty and SPL from one tool — each with its own remembered context.</a:t>
+              <a:t>Switch between Mighty and SPL — each remembers its own module list, country and context.</a:t>
             </a:r>
             <a:endParaRPr lang="en-US" sz="1350" dirty="0"/>
           </a:p>
@@ -8212,7 +8783,7 @@
                 <a:ea typeface="Calibri" pitchFamily="34" charset="-122"/>
                 <a:cs typeface="Calibri" pitchFamily="34" charset="-120"/>
               </a:rPr>
-              <a:t>Dependency sources</a:t>
+              <a:t>App module config</a:t>
             </a:r>
             <a:endParaRPr lang="en-US" sz="1600" dirty="0"/>
           </a:p>
@@ -8254,7 +8825,7 @@
                 <a:ea typeface="Calibri" pitchFamily="34" charset="-122"/>
                 <a:cs typeface="Calibri" pitchFamily="34" charset="-120"/>
               </a:rPr>
-              <a:t>Add shared / core libraries so imported routes resolve as if they were local.</a:t>
+              <a:t>The entry repo and its sub-modules are prepopulated from a per-app config — edit inline, or save as the default.</a:t>
             </a:r>
             <a:endParaRPr lang="en-US" sz="1400" dirty="0"/>
           </a:p>

</xml_diff>